<commit_message>
Add LLM routing, sandboxed code-gen agent, and UI escalation.
Adds optional LLM template routing, AgentCoder-style sandboxed pandas code generation with validation loop, escalation dialog to Advanced mode, demo typo toggle for correction, and updated docs/tests. Secrets stay in local .env only; .env.example documents config keys.

Co-authored-by: Cursor <cursoragent@cursor.com>
</commit_message>
<xml_diff>
--- a/docs/Clinical_Lab_Analysis_System.pptx
+++ b/docs/Clinical_Lab_Analysis_System.pptx
@@ -3804,7 +3804,7 @@
           <a:lstStyle/>
           <a:p>
             <a:r>
-              <a:t>Controlled AI / NLP (no LLM)</a:t>
+              <a:t>Controlled AI / NLP (optional LLM)</a:t>
             </a:r>
           </a:p>
         </p:txBody>
@@ -3836,7 +3836,7 @@
               <a:defRPr sz="1800"/>
             </a:pPr>
             <a:r>
-              <a:t>Rule-based; never generates free-form code; rejects unmappable input.</a:t>
+              <a:t>Never generates free-form code; rejects unmappable input.</a:t>
             </a:r>
           </a:p>
           <a:p>
@@ -3844,7 +3844,7 @@
               <a:defRPr sz="1800"/>
             </a:pPr>
             <a:r>
-              <a:t>No LLM in the MVP (reliable, testable, reproducible); LLM-assisted router is future work.</a:t>
+              <a:t>Rule-based by default; optional LLM-assisted fallback (Anthropic/OpenAI/Gemini) when an API key is set - model only selects a template.</a:t>
             </a:r>
           </a:p>
         </p:txBody>

</xml_diff>

<commit_message>
Refresh presentation deck: 12 questions, LLM/code-gen, Part-1 data slide.
Regenerate the .pptx from SLIDES.md (now 14 slides), add a reproducible docs/build_pptx.py builder, and align with the Part 1 dataset document.
</commit_message>
<xml_diff>
--- a/docs/Clinical_Lab_Analysis_System.pptx
+++ b/docs/Clinical_Lab_Analysis_System.pptx
@@ -17,6 +17,8 @@
     <p:sldId id="265" r:id="rId16"/>
     <p:sldId id="266" r:id="rId17"/>
     <p:sldId id="267" r:id="rId18"/>
+    <p:sldId id="268" r:id="rId19"/>
+    <p:sldId id="269" r:id="rId20"/>
   </p:sldIdLst>
   <p:sldSz cx="9144000" cy="6858000" type="screen4x3"/>
   <p:notesSz cx="6858000" cy="9144000"/>
@@ -3180,7 +3182,7 @@
           <a:lstStyle/>
           <a:p>
             <a:r>
-              <a:t>Quality / engineering</a:t>
+              <a:t>User interface</a:t>
             </a:r>
           </a:p>
         </p:txBody>
@@ -3197,30 +3199,36 @@
         </p:nvSpPr>
         <p:spPr/>
         <p:txBody>
-          <a:bodyPr/>
-          <a:lstStyle/>
-          <a:p>
-            <a:pPr>
-              <a:defRPr sz="1800"/>
-            </a:pPr>
-            <a:r>
-              <a:t>Modular design, single source of truth, docstrings.</a:t>
-            </a:r>
-          </a:p>
-          <a:p>
-            <a:pPr>
-              <a:defRPr sz="1800"/>
-            </a:pPr>
-            <a:r>
-              <a:t>72 automated tests, ~94% coverage (85% gate enforced).</a:t>
-            </a:r>
-          </a:p>
-          <a:p>
-            <a:pPr>
-              <a:defRPr sz="1800"/>
-            </a:pPr>
-            <a:r>
-              <a:t>Managed with uv; clean git history.</a:t>
+          <a:bodyPr wrap="square">
+            <a:normAutofit/>
+          </a:bodyPr>
+          <a:lstStyle/>
+          <a:p>
+            <a:pPr/>
+            <a:r>
+              <a:rPr sz="1800"/>
+              <a:t>Three modes: Rules only | Rules, then AI | Advanced: AI writes code.</a:t>
+            </a:r>
+          </a:p>
+          <a:p>
+            <a:pPr/>
+            <a:r>
+              <a:rPr sz="1800"/>
+              <a:t>Question selection + dynamic inputs + help captions.</a:t>
+            </a:r>
+          </a:p>
+          <a:p>
+            <a:pPr/>
+            <a:r>
+              <a:rPr sz="1800"/>
+              <a:t>Escalation dialog: if a template cannot match, one click re-runs in Advanced.</a:t>
+            </a:r>
+          </a:p>
+          <a:p>
+            <a:pPr/>
+            <a:r>
+              <a:rPr sz="1800"/>
+              <a:t>Results: metric cards, trend chart, color-coded status, generated-code tab.</a:t>
             </a:r>
           </a:p>
         </p:txBody>
@@ -3259,7 +3267,7 @@
           <a:lstStyle/>
           <a:p>
             <a:r>
-              <a:t>Demo</a:t>
+              <a:t>Evaluation</a:t>
             </a:r>
           </a:p>
         </p:txBody>
@@ -3276,30 +3284,29 @@
         </p:nvSpPr>
         <p:spPr/>
         <p:txBody>
-          <a:bodyPr/>
-          <a:lstStyle/>
-          <a:p>
-            <a:pPr>
-              <a:defRPr sz="1800"/>
-            </a:pPr>
-            <a:r>
-              <a:t>Structured trend question -&gt; chart.</a:t>
-            </a:r>
-          </a:p>
-          <a:p>
-            <a:pPr>
-              <a:defRPr sz="1800"/>
-            </a:pPr>
-            <a:r>
-              <a:t>Same question in natural language -&gt; identical result.</a:t>
-            </a:r>
-          </a:p>
-          <a:p>
-            <a:pPr>
-              <a:defRPr sz="1800"/>
-            </a:pPr>
-            <a:r>
-              <a:t>Edge case: unknown admission -&gt; clear 'not found' message.</a:t>
+          <a:bodyPr wrap="square">
+            <a:normAutofit/>
+          </a:bodyPr>
+          <a:lstStyle/>
+          <a:p>
+            <a:pPr/>
+            <a:r>
+              <a:rPr sz="1800"/>
+              <a:t>All 12 question types pass execution + validation across multiple admissions.</a:t>
+            </a:r>
+          </a:p>
+          <a:p>
+            <a:pPr/>
+            <a:r>
+              <a:rPr sz="1800"/>
+              <a:t>Examples: Chloride latest 103 mEq/L; Hematocrit trend 57.9% -&gt; 44.4%; pO2 first 82 / last 103 (+21 mm Hg).</a:t>
+            </a:r>
+          </a:p>
+          <a:p>
+            <a:pPr/>
+            <a:r>
+              <a:rPr sz="1800"/>
+              <a:t>NL queries reproduce the same results as the structured dropdown.</a:t>
             </a:r>
           </a:p>
         </p:txBody>
@@ -3338,6 +3345,169 @@
           <a:lstStyle/>
           <a:p>
             <a:r>
+              <a:t>Quality and engineering</a:t>
+            </a:r>
+          </a:p>
+        </p:txBody>
+      </p:sp>
+      <p:sp>
+        <p:nvSpPr>
+          <p:cNvPr id="3" name="Content Placeholder 2"/>
+          <p:cNvSpPr>
+            <a:spLocks noGrp="1"/>
+          </p:cNvSpPr>
+          <p:nvPr>
+            <p:ph idx="1"/>
+          </p:nvPr>
+        </p:nvSpPr>
+        <p:spPr/>
+        <p:txBody>
+          <a:bodyPr wrap="square">
+            <a:normAutofit/>
+          </a:bodyPr>
+          <a:lstStyle/>
+          <a:p>
+            <a:pPr/>
+            <a:r>
+              <a:rPr sz="1800"/>
+              <a:t>Modular design, single source of truth, docstrings.</a:t>
+            </a:r>
+          </a:p>
+          <a:p>
+            <a:pPr/>
+            <a:r>
+              <a:rPr sz="1800"/>
+              <a:t>159 automated tests, ~93% line coverage (85% gate); all run offline.</a:t>
+            </a:r>
+          </a:p>
+          <a:p>
+            <a:pPr/>
+            <a:r>
+              <a:rPr sz="1800"/>
+              <a:t>Managed with uv; secrets only in .env; clean, logical git history.</a:t>
+            </a:r>
+          </a:p>
+        </p:txBody>
+      </p:sp>
+    </p:spTree>
+  </p:cSld>
+  <p:clrMapOvr>
+    <a:masterClrMapping/>
+  </p:clrMapOvr>
+</p:sld>
+</file>
+
+<file path=ppt/slides/slide13.xml><?xml version="1.0" encoding="utf-8"?>
+<p:sld xmlns:a="http://schemas.openxmlformats.org/drawingml/2006/main" xmlns:p="http://schemas.openxmlformats.org/presentationml/2006/main" xmlns:r="http://schemas.openxmlformats.org/officeDocument/2006/relationships">
+  <p:cSld>
+    <p:spTree>
+      <p:nvGrpSpPr>
+        <p:cNvPr id="1" name=""/>
+        <p:cNvGrpSpPr/>
+        <p:nvPr/>
+      </p:nvGrpSpPr>
+      <p:grpSpPr/>
+      <p:sp>
+        <p:nvSpPr>
+          <p:cNvPr id="2" name="Title 1"/>
+          <p:cNvSpPr>
+            <a:spLocks noGrp="1"/>
+          </p:cNvSpPr>
+          <p:nvPr>
+            <p:ph type="title"/>
+          </p:nvPr>
+        </p:nvSpPr>
+        <p:spPr/>
+        <p:txBody>
+          <a:bodyPr/>
+          <a:lstStyle/>
+          <a:p>
+            <a:r>
+              <a:t>Demo</a:t>
+            </a:r>
+          </a:p>
+        </p:txBody>
+      </p:sp>
+      <p:sp>
+        <p:nvSpPr>
+          <p:cNvPr id="3" name="Content Placeholder 2"/>
+          <p:cNvSpPr>
+            <a:spLocks noGrp="1"/>
+          </p:cNvSpPr>
+          <p:nvPr>
+            <p:ph idx="1"/>
+          </p:nvPr>
+        </p:nvSpPr>
+        <p:spPr/>
+        <p:txBody>
+          <a:bodyPr wrap="square">
+            <a:normAutofit/>
+          </a:bodyPr>
+          <a:lstStyle/>
+          <a:p>
+            <a:pPr/>
+            <a:r>
+              <a:rPr sz="1800"/>
+              <a:t>Structured trend question -&gt; chart and generated code.</a:t>
+            </a:r>
+          </a:p>
+          <a:p>
+            <a:pPr/>
+            <a:r>
+              <a:rPr sz="1800"/>
+              <a:t>Same question in natural language -&gt; identical result.</a:t>
+            </a:r>
+          </a:p>
+          <a:p>
+            <a:pPr/>
+            <a:r>
+              <a:rPr sz="1800"/>
+              <a:t>Force a correction (demo typo toggle) -&gt; the corrector repairs the code.</a:t>
+            </a:r>
+          </a:p>
+          <a:p>
+            <a:pPr/>
+            <a:r>
+              <a:rPr sz="1800"/>
+              <a:t>Edge case: unknown admission -&gt; clear "not found".</a:t>
+            </a:r>
+          </a:p>
+        </p:txBody>
+      </p:sp>
+    </p:spTree>
+  </p:cSld>
+  <p:clrMapOvr>
+    <a:masterClrMapping/>
+  </p:clrMapOvr>
+</p:sld>
+</file>
+
+<file path=ppt/slides/slide14.xml><?xml version="1.0" encoding="utf-8"?>
+<p:sld xmlns:a="http://schemas.openxmlformats.org/drawingml/2006/main" xmlns:p="http://schemas.openxmlformats.org/presentationml/2006/main" xmlns:r="http://schemas.openxmlformats.org/officeDocument/2006/relationships">
+  <p:cSld>
+    <p:spTree>
+      <p:nvGrpSpPr>
+        <p:cNvPr id="1" name=""/>
+        <p:cNvGrpSpPr/>
+        <p:nvPr/>
+      </p:nvGrpSpPr>
+      <p:grpSpPr/>
+      <p:sp>
+        <p:nvSpPr>
+          <p:cNvPr id="2" name="Title 1"/>
+          <p:cNvSpPr>
+            <a:spLocks noGrp="1"/>
+          </p:cNvSpPr>
+          <p:nvPr>
+            <p:ph type="title"/>
+          </p:nvPr>
+        </p:nvSpPr>
+        <p:spPr/>
+        <p:txBody>
+          <a:bodyPr/>
+          <a:lstStyle/>
+          <a:p>
+            <a:r>
               <a:t>Limitations and future work</a:t>
             </a:r>
           </a:p>
@@ -3355,22 +3525,22 @@
         </p:nvSpPr>
         <p:spPr/>
         <p:txBody>
-          <a:bodyPr/>
-          <a:lstStyle/>
-          <a:p>
-            <a:pPr>
-              <a:defRPr sz="1800"/>
-            </a:pPr>
-            <a:r>
-              <a:t>Predefined questions only (by design).</a:t>
-            </a:r>
-          </a:p>
-          <a:p>
-            <a:pPr>
-              <a:defRPr sz="1800"/>
-            </a:pPr>
-            <a:r>
-              <a:t>Future: LLM-assisted routing, broader question set, live SQL backend.</a:t>
+          <a:bodyPr wrap="square">
+            <a:normAutofit/>
+          </a:bodyPr>
+          <a:lstStyle/>
+          <a:p>
+            <a:pPr/>
+            <a:r>
+              <a:rPr sz="1800"/>
+              <a:t>Predefined questions remain the trusted, default core; free-form code-gen is optional and guarded.</a:t>
+            </a:r>
+          </a:p>
+          <a:p>
+            <a:pPr/>
+            <a:r>
+              <a:rPr sz="1800"/>
+              <a:t>Future: broaden the guarded code-gen catalog, a live SQL backend, richer charts, and presentation polish.</a:t>
             </a:r>
           </a:p>
         </p:txBody>
@@ -3409,7 +3579,7 @@
           <a:lstStyle/>
           <a:p>
             <a:r>
-              <a:t>Problem</a:t>
+              <a:t>Problem and goal</a:t>
             </a:r>
           </a:p>
         </p:txBody>
@@ -3426,30 +3596,29 @@
         </p:nvSpPr>
         <p:spPr/>
         <p:txBody>
-          <a:bodyPr/>
-          <a:lstStyle/>
-          <a:p>
-            <a:pPr>
-              <a:defRPr sz="1800"/>
-            </a:pPr>
-            <a:r>
+          <a:bodyPr wrap="square">
+            <a:normAutofit/>
+          </a:bodyPr>
+          <a:lstStyle/>
+          <a:p>
+            <a:pPr/>
+            <a:r>
+              <a:rPr sz="1800"/>
               <a:t>Raw MIMIC-III lab data is large and hard to query ad hoc.</a:t>
             </a:r>
           </a:p>
           <a:p>
-            <a:pPr>
-              <a:defRPr sz="1800"/>
-            </a:pPr>
-            <a:r>
-              <a:t>Goal: automatically answer a limited set of clinical questions about an admission, a lab test, or a patient.</a:t>
-            </a:r>
-          </a:p>
-          <a:p>
-            <a:pPr>
-              <a:defRPr sz="1800"/>
-            </a:pPr>
-            <a:r>
-              <a:t>Must be reliable and transparent.</a:t>
+            <a:pPr/>
+            <a:r>
+              <a:rPr sz="1800"/>
+              <a:t>Goal: automatically answer a defined set of clinical questions about an admission, a lab test, or a patient - reliably, transparently, reproducibly.</a:t>
+            </a:r>
+          </a:p>
+          <a:p>
+            <a:pPr/>
+            <a:r>
+              <a:rPr sz="1800"/>
+              <a:t>Each answer ships with the exact code that produced it.</a:t>
             </a:r>
           </a:p>
         </p:txBody>
@@ -3488,7 +3657,7 @@
           <a:lstStyle/>
           <a:p>
             <a:r>
-              <a:t>What the system does</a:t>
+              <a:t>Data: source and preparation (Part 1)</a:t>
             </a:r>
           </a:p>
         </p:txBody>
@@ -3505,30 +3674,36 @@
         </p:nvSpPr>
         <p:spPr/>
         <p:txBody>
-          <a:bodyPr/>
-          <a:lstStyle/>
-          <a:p>
-            <a:pPr>
-              <a:defRPr sz="1800"/>
-            </a:pPr>
-            <a:r>
-              <a:t>Takes one predefined question + parameters.</a:t>
-            </a:r>
-          </a:p>
-          <a:p>
-            <a:pPr>
-              <a:defRPr sz="1800"/>
-            </a:pPr>
-            <a:r>
-              <a:t>Generates executable Python code, runs it, validates, corrects if needed, presents the result and the code.</a:t>
-            </a:r>
-          </a:p>
-          <a:p>
-            <a:pPr>
-              <a:defRPr sz="1800"/>
-            </a:pPr>
-            <a:r>
-              <a:t>11 supported question types.</a:t>
+          <a:bodyPr wrap="square">
+            <a:normAutofit/>
+          </a:bodyPr>
+          <a:lstStyle/>
+          <a:p>
+            <a:pPr/>
+            <a:r>
+              <a:rPr sz="1800"/>
+              <a:t>Source: MIMIC-III tables ADMISSIONS, LABEVENTS, and D_LABITEMS.</a:t>
+            </a:r>
+          </a:p>
+          <a:p>
+            <a:pPr/>
+            <a:r>
+              <a:rPr sz="1800"/>
+              <a:t>Schema inspection: confirmed required fields exist (HADM_ID, ITEMID, CHARTTIME, VALUENUM, VALUEUOM, FLAG, LABEL) and checked missing values.</a:t>
+            </a:r>
+          </a:p>
+          <a:p>
+            <a:pPr/>
+            <a:r>
+              <a:rPr sz="1800"/>
+              <a:t>Cleaning/filtering: drop lab rows without HADM_ID (needed for the join), keep valid VALUENUM for numeric analysis, join LABEVENTS to ADMISSIONS on HADM_ID, add readable lab names from D_LABITEMS (ITEMID -&gt; LABEL).</a:t>
+            </a:r>
+          </a:p>
+          <a:p>
+            <a:pPr/>
+            <a:r>
+              <a:rPr sz="1800"/>
+              <a:t>Result: one cleaned, merged dataset used by every question.</a:t>
             </a:r>
           </a:p>
         </p:txBody>
@@ -3567,7 +3742,7 @@
           <a:lstStyle/>
           <a:p>
             <a:r>
-              <a:t>Architecture</a:t>
+              <a:t>What the system does</a:t>
             </a:r>
           </a:p>
         </p:txBody>
@@ -3584,30 +3759,29 @@
         </p:nvSpPr>
         <p:spPr/>
         <p:txBody>
-          <a:bodyPr/>
-          <a:lstStyle/>
-          <a:p>
-            <a:pPr>
-              <a:defRPr sz="1800"/>
-            </a:pPr>
-            <a:r>
-              <a:t>Layered, registry-driven pipeline:</a:t>
-            </a:r>
-          </a:p>
-          <a:p>
-            <a:pPr>
-              <a:defRPr sz="1800"/>
-            </a:pPr>
-            <a:r>
-              <a:t>question id -&gt; generate code -&gt; execute -&gt; validate -&gt; correct -&gt; present.</a:t>
-            </a:r>
-          </a:p>
-          <a:p>
-            <a:pPr>
-              <a:defRPr sz="1800"/>
-            </a:pPr>
-            <a:r>
-              <a:t>One question registry is the single source of truth (UI, generation, validation, pipeline read from it).</a:t>
+          <a:bodyPr wrap="square">
+            <a:normAutofit/>
+          </a:bodyPr>
+          <a:lstStyle/>
+          <a:p>
+            <a:pPr/>
+            <a:r>
+              <a:rPr sz="1800"/>
+              <a:t>Takes one predefined question + parameters.</a:t>
+            </a:r>
+          </a:p>
+          <a:p>
+            <a:pPr/>
+            <a:r>
+              <a:rPr sz="1800"/>
+              <a:t>Generates executable Python code, runs it, validates, corrects if needed, presents the result and the generated code.</a:t>
+            </a:r>
+          </a:p>
+          <a:p>
+            <a:pPr/>
+            <a:r>
+              <a:rPr sz="1800"/>
+              <a:t>12 supported question types (the 5 base questions from Part 1, plus 7).</a:t>
             </a:r>
           </a:p>
         </p:txBody>
@@ -3646,7 +3820,7 @@
           <a:lstStyle/>
           <a:p>
             <a:r>
-              <a:t>The 11 questions</a:t>
+              <a:t>Architecture</a:t>
             </a:r>
           </a:p>
         </p:txBody>
@@ -3663,30 +3837,22 @@
         </p:nvSpPr>
         <p:spPr/>
         <p:txBody>
-          <a:bodyPr/>
-          <a:lstStyle/>
-          <a:p>
-            <a:pPr>
-              <a:defRPr sz="1800"/>
-            </a:pPr>
-            <a:r>
-              <a:t>Abnormal results; latest value; trend; all tests; first-vs-last.</a:t>
-            </a:r>
-          </a:p>
-          <a:p>
-            <a:pPr>
-              <a:defRPr sz="1800"/>
-            </a:pPr>
-            <a:r>
-              <a:t>Summary stats; abnormal vs normal counts; abnormal-by-test.</a:t>
-            </a:r>
-          </a:p>
-          <a:p>
-            <a:pPr>
-              <a:defRPr sz="1800"/>
-            </a:pPr>
-            <a:r>
-              <a:t>Distinct abnormal tests; date-range values; patient admissions.</a:t>
+          <a:bodyPr wrap="square">
+            <a:normAutofit/>
+          </a:bodyPr>
+          <a:lstStyle/>
+          <a:p>
+            <a:pPr/>
+            <a:r>
+              <a:rPr sz="1800"/>
+              <a:t>Layered, registry-driven pipeline: question id -&gt; generate code -&gt; execute -&gt; validate -&gt; correct -&gt; present.</a:t>
+            </a:r>
+          </a:p>
+          <a:p>
+            <a:pPr/>
+            <a:r>
+              <a:rPr sz="1800"/>
+              <a:t>One question registry is the single source of truth: UI, generation, validation, and pipeline all read from it - adding a question is a one-place change.</a:t>
             </a:r>
           </a:p>
         </p:txBody>
@@ -3725,7 +3891,7 @@
           <a:lstStyle/>
           <a:p>
             <a:r>
-              <a:t>Code generation, validation, correction</a:t>
+              <a:t>The 12 questions</a:t>
             </a:r>
           </a:p>
         </p:txBody>
@@ -3742,30 +3908,29 @@
         </p:nvSpPr>
         <p:spPr/>
         <p:txBody>
-          <a:bodyPr/>
-          <a:lstStyle/>
-          <a:p>
-            <a:pPr>
-              <a:defRPr sz="1800"/>
-            </a:pPr>
-            <a:r>
-              <a:t>Template generation, e.g. result = get_lab_trend(107521, 51221).</a:t>
-            </a:r>
-          </a:p>
-          <a:p>
-            <a:pPr>
-              <a:defRPr sz="1800"/>
-            </a:pPr>
-            <a:r>
-              <a:t>Validation: expected columns + per-question rules.</a:t>
-            </a:r>
-          </a:p>
-          <a:p>
-            <a:pPr>
-              <a:defRPr sz="1800"/>
-            </a:pPr>
-            <a:r>
-              <a:t>Correction: bounded rule-based retry for generated-code errors.</a:t>
+          <a:bodyPr wrap="square">
+            <a:normAutofit/>
+          </a:bodyPr>
+          <a:lstStyle/>
+          <a:p>
+            <a:pPr/>
+            <a:r>
+              <a:rPr sz="1800"/>
+              <a:t>Base (Part 1): abnormal results, latest value, trend over time, all tests, first-vs-last comparison.</a:t>
+            </a:r>
+          </a:p>
+          <a:p>
+            <a:pPr/>
+            <a:r>
+              <a:rPr sz="1800"/>
+              <a:t>Added: summary stats (min/max/mean), abnormal vs normal counts, abnormal-by-test, distinct abnormal tests, values in a date range, patient admissions.</a:t>
+            </a:r>
+          </a:p>
+          <a:p>
+            <a:pPr/>
+            <a:r>
+              <a:rPr sz="1800"/>
+              <a:t>Dataset-wide aggregate: abnormal vs normal counts across all admissions.</a:t>
             </a:r>
           </a:p>
         </p:txBody>
@@ -3804,7 +3969,7 @@
           <a:lstStyle/>
           <a:p>
             <a:r>
-              <a:t>Controlled AI / NLP (optional LLM)</a:t>
+              <a:t>Code generation, validation, correction</a:t>
             </a:r>
           </a:p>
         </p:txBody>
@@ -3821,30 +3986,29 @@
         </p:nvSpPr>
         <p:spPr/>
         <p:txBody>
-          <a:bodyPr/>
-          <a:lstStyle/>
-          <a:p>
-            <a:pPr>
-              <a:defRPr sz="1800"/>
-            </a:pPr>
-            <a:r>
-              <a:t>Optional natural-language box routes free text to ONE supported template.</a:t>
-            </a:r>
-          </a:p>
-          <a:p>
-            <a:pPr>
-              <a:defRPr sz="1800"/>
-            </a:pPr>
-            <a:r>
-              <a:t>Never generates free-form code; rejects unmappable input.</a:t>
-            </a:r>
-          </a:p>
-          <a:p>
-            <a:pPr>
-              <a:defRPr sz="1800"/>
-            </a:pPr>
-            <a:r>
-              <a:t>Rule-based by default; optional LLM-assisted fallback (Anthropic/OpenAI/Gemini) when an API key is set - model only selects a template.</a:t>
+          <a:bodyPr wrap="square">
+            <a:normAutofit/>
+          </a:bodyPr>
+          <a:lstStyle/>
+          <a:p>
+            <a:pPr/>
+            <a:r>
+              <a:rPr sz="1800"/>
+              <a:t>Template generation: result = get_lab_trend(107521, 51221).</a:t>
+            </a:r>
+          </a:p>
+          <a:p>
+            <a:pPr/>
+            <a:r>
+              <a:rPr sz="1800"/>
+              <a:t>Validation: expected columns + per-question rules (e.g. only-abnormal, single-row, time-ascending, counts add up).</a:t>
+            </a:r>
+          </a:p>
+          <a:p>
+            <a:pPr/>
+            <a:r>
+              <a:rPr sz="1800"/>
+              <a:t>Correction: bounded rule-based retry that repairs generated-code errors.</a:t>
             </a:r>
           </a:p>
         </p:txBody>
@@ -3883,7 +4047,7 @@
           <a:lstStyle/>
           <a:p>
             <a:r>
-              <a:t>User interface</a:t>
+              <a:t>Controlled natural language (optional LLM routing)</a:t>
             </a:r>
           </a:p>
         </p:txBody>
@@ -3900,30 +4064,29 @@
         </p:nvSpPr>
         <p:spPr/>
         <p:txBody>
-          <a:bodyPr/>
-          <a:lstStyle/>
-          <a:p>
-            <a:pPr>
-              <a:defRPr sz="1800"/>
-            </a:pPr>
-            <a:r>
-              <a:t>Question selection + dynamic inputs + per-question help captions.</a:t>
-            </a:r>
-          </a:p>
-          <a:p>
-            <a:pPr>
-              <a:defRPr sz="1800"/>
-            </a:pPr>
-            <a:r>
-              <a:t>Results: metric cards, trend chart, color-coded status.</a:t>
-            </a:r>
-          </a:p>
-          <a:p>
-            <a:pPr>
-              <a:defRPr sz="1800"/>
-            </a:pPr>
-            <a:r>
-              <a:t>Tabs: result, generated code, validation, correction attempts.</a:t>
+          <a:bodyPr wrap="square">
+            <a:normAutofit/>
+          </a:bodyPr>
+          <a:lstStyle/>
+          <a:p>
+            <a:pPr/>
+            <a:r>
+              <a:rPr sz="1800"/>
+              <a:t>Optional free-text box routes a question to ONE supported template.</a:t>
+            </a:r>
+          </a:p>
+          <a:p>
+            <a:pPr/>
+            <a:r>
+              <a:rPr sz="1800"/>
+              <a:t>The model only selects a template id + parameters - it never writes code, and it may decline when nothing fits (no forced approximate match).</a:t>
+            </a:r>
+          </a:p>
+          <a:p>
+            <a:pPr/>
+            <a:r>
+              <a:rPr sz="1800"/>
+              <a:t>Rule-based by default; optional LLM fallback (Anthropic/OpenAI/Gemini) when an API key is set. Keys live only in a gitignored .env.</a:t>
             </a:r>
           </a:p>
         </p:txBody>
@@ -3962,7 +4125,7 @@
           <a:lstStyle/>
           <a:p>
             <a:r>
-              <a:t>Evaluation</a:t>
+              <a:t>Advanced: guarded LLM code-generation (AgentCoder-style)</a:t>
             </a:r>
           </a:p>
         </p:txBody>
@@ -3979,30 +4142,29 @@
         </p:nvSpPr>
         <p:spPr/>
         <p:txBody>
-          <a:bodyPr/>
-          <a:lstStyle/>
-          <a:p>
-            <a:pPr>
-              <a:defRPr sz="1800"/>
-            </a:pPr>
-            <a:r>
-              <a:t>All question types pass execution + validation across multiple admissions.</a:t>
-            </a:r>
-          </a:p>
-          <a:p>
-            <a:pPr>
-              <a:defRPr sz="1800"/>
-            </a:pPr>
-            <a:r>
-              <a:t>Chloride latest 103 mEq/L; Hematocrit trend 57.9% -&gt; 44.4%.</a:t>
-            </a:r>
-          </a:p>
-          <a:p>
-            <a:pPr>
-              <a:defRPr sz="1800"/>
-            </a:pPr>
-            <a:r>
-              <a:t>pO2 first 82 / last 103 (difference +21 mm Hg).</a:t>
+          <a:bodyPr wrap="square">
+            <a:normAutofit/>
+          </a:bodyPr>
+          <a:lstStyle/>
+          <a:p>
+            <a:pPr/>
+            <a:r>
+              <a:rPr sz="1800"/>
+              <a:t>Optional "Advanced" mode: an LLM programmer agent writes pandas code for free-form questions, in a generate -&gt; run -&gt; validate -&gt; refine loop.</a:t>
+            </a:r>
+          </a:p>
+          <a:p>
+            <a:pPr/>
+            <a:r>
+              <a:rPr sz="1800"/>
+              <a:t>Guardrails: AST allowlist (no imports, dunders, file/network, loops) + restricted exec exposing only pd and a read-only df, with a timeout and row cap; a deterministic validator gates every result.</a:t>
+            </a:r>
+          </a:p>
+          <a:p>
+            <a:pPr/>
+            <a:r>
+              <a:rPr sz="1800"/>
+              <a:t>Inspired by AgentCoder (arXiv 2312.13010); lightweight, in-repo orchestration (no CrewAI/AutoGen). Off by default and clearly labelled experimental.</a:t>
             </a:r>
           </a:p>
         </p:txBody>

</xml_diff>

<commit_message>
Sync docs with the role-based UI and current test suite.
Update DEMO, REPORT, SLIDES (+ regenerated deck), TEST_REPORT, TODO, and
the gap analysis for the Welcome page and Doctor/Researcher workspaces,
unify the drifting test counts to the verified 170 tests / 94% coverage,
and fill the decision log's missing July-August entries (drive
auto-download, role workspaces, UI polish, screenshot refresh).
</commit_message>
<xml_diff>
--- a/docs/Clinical_Lab_Analysis_System.pptx
+++ b/docs/Clinical_Lab_Analysis_System.pptx
@@ -3182,7 +3182,7 @@
           <a:lstStyle/>
           <a:p>
             <a:r>
-              <a:t>User interface</a:t>
+              <a:t>User interface: role-based workspaces</a:t>
             </a:r>
           </a:p>
         </p:txBody>
@@ -3207,28 +3207,28 @@
             <a:pPr/>
             <a:r>
               <a:rPr sz="1800"/>
-              <a:t>Three modes: Rules only | Rules, then AI | Advanced: AI writes code.</a:t>
+              <a:t>Welcome page with two roles: Doctor (admission-level review) and Researcher (dataset-level analysis) - switch anytime, same pipeline.</a:t>
             </a:r>
           </a:p>
           <a:p>
             <a:pPr/>
             <a:r>
               <a:rPr sz="1800"/>
-              <a:t>Question selection + dynamic inputs + help captions.</a:t>
+              <a:t>Each workspace surfaces its role's questions first as clickable cards.</a:t>
             </a:r>
           </a:p>
           <a:p>
             <a:pPr/>
             <a:r>
               <a:rPr sz="1800"/>
-              <a:t>Escalation dialog: if a template cannot match, one click re-runs in Advanced.</a:t>
+              <a:t>Three NL modes: Rules only | Rules, then AI | Advanced: AI writes code; escalation dialog re-runs an unmatched query in Advanced with one click.</a:t>
             </a:r>
           </a:p>
           <a:p>
             <a:pPr/>
             <a:r>
               <a:rPr sz="1800"/>
-              <a:t>Results: metric cards, trend chart, color-coded status, generated-code tab.</a:t>
+              <a:t>Results: metric cards, trend chart, color-coded status, and tabs for the result, validation audit, correction attempts, and generated code.</a:t>
             </a:r>
           </a:p>
         </p:txBody>
@@ -3377,7 +3377,7 @@
             <a:pPr/>
             <a:r>
               <a:rPr sz="1800"/>
-              <a:t>159 automated tests, ~93% line coverage (85% gate); all run offline.</a:t>
+              <a:t>170 automated tests, ~94% line coverage (85% gate); all run offline.</a:t>
             </a:r>
           </a:p>
           <a:p>
@@ -3444,6 +3444,13 @@
             <a:normAutofit/>
           </a:bodyPr>
           <a:lstStyle/>
+          <a:p>
+            <a:pPr/>
+            <a:r>
+              <a:rPr sz="1800"/>
+              <a:t>Welcome page -&gt; enter the Doctor workspace (role cards).</a:t>
+            </a:r>
+          </a:p>
           <a:p>
             <a:pPr/>
             <a:r>

</xml_diff>